<commit_message>
Add sweep results figure, data, and update results slide
- make_plot.py: two-panel matplotlib figure (injection sweep + heterophily bars)
- sweep_results.json: Cora 6-ratio sweep + Texas heterophily raw numbers
- research_figure.png: final dark-theme PNG (160 dpi)
- update_results_slide.py: patches slide 6 of research_framework.pptx in-place
- research_framework.pptx: slide 6 now embeds the figure + key-numbers table
  and 4 takeaway bullets replacing the earlier placeholder text

Co-Authored-By: Claude Sonnet 4.6 <noreply@anthropic.com>
</commit_message>
<xml_diff>
--- a/research_framework.pptx
+++ b/research_framework.pptx
@@ -14898,8 +14898,8 @@
         </p:nvSpPr>
         <p:spPr>
           <a:xfrm>
-            <a:off x="502920" y="164592"/>
-            <a:ext cx="11430000" cy="566928"/>
+            <a:off x="502920" y="137160"/>
+            <a:ext cx="11430000" cy="530352"/>
           </a:xfrm>
           <a:prstGeom prst="rect">
             <a:avLst/>
@@ -14914,12 +14914,12 @@
           <a:p>
             <a:pPr algn="l"/>
             <a:r>
-              <a:rPr sz="2800" b="1" i="0">
+              <a:rPr sz="2600" b="1" i="0">
                 <a:solidFill>
                   <a:srgbClr val="FFFFFF"/>
                 </a:solidFill>
               </a:rPr>
-              <a:t>Experimental Results</a:t>
+              <a:t>Experimental Results  ·  Trust Gate vs. Baselines</a:t>
             </a:r>
           </a:p>
         </p:txBody>
@@ -14932,8 +14932,8 @@
         </p:nvSpPr>
         <p:spPr>
           <a:xfrm>
-            <a:off x="502920" y="731520"/>
-            <a:ext cx="11430000" cy="347472"/>
+            <a:off x="502920" y="667512"/>
+            <a:ext cx="11430000" cy="320040"/>
           </a:xfrm>
           <a:prstGeom prst="rect">
             <a:avLst/>
@@ -14948,12 +14948,12 @@
           <a:p>
             <a:pPr algn="l"/>
             <a:r>
-              <a:rPr sz="1400" b="0" i="0">
+              <a:rPr sz="1300" b="0" i="0">
                 <a:solidFill>
                   <a:srgbClr val="8A93A8"/>
                 </a:solidFill>
               </a:rPr>
-              <a:t>Accuracy vs. injection ratio (Cora) and heterophily (Texas) — 3 seeds</a:t>
+              <a:t>Cora (injection sweep, 3 seeds)  ·  Texas WebKB (heterophily, 3 splits)  ·  200 epochs each</a:t>
             </a:r>
           </a:p>
         </p:txBody>
@@ -14966,7 +14966,7 @@
         </p:nvCxnSpPr>
         <p:spPr>
           <a:xfrm>
-            <a:off x="502920" y="1133856"/>
+            <a:off x="502920" y="1024128"/>
             <a:ext cx="11183112" cy="0"/>
           </a:xfrm>
           <a:prstGeom prst="line">
@@ -14993,36 +14993,1890 @@
           </a:fontRef>
         </p:style>
       </p:cxnSp>
-      <p:sp>
-        <p:nvSpPr>
-          <p:cNvPr id="7" name="TextBox 6"/>
-          <p:cNvSpPr txBox="1"/>
-          <p:nvPr/>
-        </p:nvSpPr>
-        <p:spPr>
-          <a:xfrm>
-            <a:off x="502920" y="2286000"/>
-            <a:ext cx="11201400" cy="457200"/>
-          </a:xfrm>
-          <a:prstGeom prst="rect">
-            <a:avLst/>
-          </a:prstGeom>
-          <a:noFill/>
-        </p:spPr>
-        <p:txBody>
-          <a:bodyPr wrap="square">
-            <a:spAutoFit/>
-          </a:bodyPr>
-          <a:lstStyle/>
-          <a:p>
-            <a:pPr algn="ctr"/>
-            <a:r>
-              <a:rPr sz="1600" b="0" i="1">
+      <p:pic>
+        <p:nvPicPr>
+          <p:cNvPr id="7" name="Picture 6" descr="research_figure.png"/>
+          <p:cNvPicPr>
+            <a:picLocks noChangeAspect="1"/>
+          </p:cNvPicPr>
+          <p:nvPr/>
+        </p:nvPicPr>
+        <p:blipFill>
+          <a:blip r:embed="rId2"/>
+          <a:stretch>
+            <a:fillRect/>
+          </a:stretch>
+        </p:blipFill>
+        <p:spPr>
+          <a:xfrm>
+            <a:off x="502920" y="1097280"/>
+            <a:ext cx="8046720" cy="3090672"/>
+          </a:xfrm>
+          <a:prstGeom prst="rect">
+            <a:avLst/>
+          </a:prstGeom>
+        </p:spPr>
+      </p:pic>
+      <p:sp>
+        <p:nvSpPr>
+          <p:cNvPr id="8" name="Rectangle 7"/>
+          <p:cNvSpPr/>
+          <p:nvPr/>
+        </p:nvSpPr>
+        <p:spPr>
+          <a:xfrm>
+            <a:off x="8732520" y="1097280"/>
+            <a:ext cx="3291840" cy="3090672"/>
+          </a:xfrm>
+          <a:prstGeom prst="rect">
+            <a:avLst/>
+          </a:prstGeom>
+          <a:solidFill>
+            <a:srgbClr val="101420"/>
+          </a:solidFill>
+          <a:ln w="10160">
+            <a:solidFill>
+              <a:srgbClr val="353C50"/>
+            </a:solidFill>
+          </a:ln>
+        </p:spPr>
+        <p:style>
+          <a:lnRef idx="1">
+            <a:schemeClr val="accent1"/>
+          </a:lnRef>
+          <a:fillRef idx="3">
+            <a:schemeClr val="accent1"/>
+          </a:fillRef>
+          <a:effectRef idx="2">
+            <a:schemeClr val="accent1"/>
+          </a:effectRef>
+          <a:fontRef idx="minor">
+            <a:schemeClr val="lt1"/>
+          </a:fontRef>
+        </p:style>
+        <p:txBody>
+          <a:bodyPr rtlCol="0" anchor="ctr"/>
+          <a:lstStyle/>
+          <a:p>
+            <a:pPr algn="ctr"/>
+          </a:p>
+        </p:txBody>
+      </p:sp>
+      <p:sp>
+        <p:nvSpPr>
+          <p:cNvPr id="9" name="TextBox 8"/>
+          <p:cNvSpPr txBox="1"/>
+          <p:nvPr/>
+        </p:nvSpPr>
+        <p:spPr>
+          <a:xfrm>
+            <a:off x="8869680" y="1207008"/>
+            <a:ext cx="3108960" cy="320040"/>
+          </a:xfrm>
+          <a:prstGeom prst="rect">
+            <a:avLst/>
+          </a:prstGeom>
+          <a:noFill/>
+        </p:spPr>
+        <p:txBody>
+          <a:bodyPr wrap="square">
+            <a:spAutoFit/>
+          </a:bodyPr>
+          <a:lstStyle/>
+          <a:p>
+            <a:pPr algn="l"/>
+            <a:r>
+              <a:rPr sz="1300" b="1" i="0">
+                <a:solidFill>
+                  <a:srgbClr val="FFFFFF"/>
+                </a:solidFill>
+              </a:rPr>
+              <a:t>Key Numbers</a:t>
+            </a:r>
+          </a:p>
+        </p:txBody>
+      </p:sp>
+      <p:sp>
+        <p:nvSpPr>
+          <p:cNvPr id="10" name="Rectangle 9"/>
+          <p:cNvSpPr/>
+          <p:nvPr/>
+        </p:nvSpPr>
+        <p:spPr>
+          <a:xfrm>
+            <a:off x="8823960" y="1572768"/>
+            <a:ext cx="3108960" cy="256032"/>
+          </a:xfrm>
+          <a:prstGeom prst="rect">
+            <a:avLst/>
+          </a:prstGeom>
+          <a:solidFill>
+            <a:srgbClr val="161C2C"/>
+          </a:solidFill>
+          <a:ln>
+            <a:noFill/>
+          </a:ln>
+        </p:spPr>
+        <p:style>
+          <a:lnRef idx="1">
+            <a:schemeClr val="accent1"/>
+          </a:lnRef>
+          <a:fillRef idx="3">
+            <a:schemeClr val="accent1"/>
+          </a:fillRef>
+          <a:effectRef idx="2">
+            <a:schemeClr val="accent1"/>
+          </a:effectRef>
+          <a:fontRef idx="minor">
+            <a:schemeClr val="lt1"/>
+          </a:fontRef>
+        </p:style>
+        <p:txBody>
+          <a:bodyPr rtlCol="0" anchor="ctr"/>
+          <a:lstStyle/>
+          <a:p>
+            <a:pPr algn="ctr"/>
+          </a:p>
+        </p:txBody>
+      </p:sp>
+      <p:sp>
+        <p:nvSpPr>
+          <p:cNvPr id="11" name="TextBox 10"/>
+          <p:cNvSpPr txBox="1"/>
+          <p:nvPr/>
+        </p:nvSpPr>
+        <p:spPr>
+          <a:xfrm>
+            <a:off x="8897112" y="1591056"/>
+            <a:ext cx="3063240" cy="228600"/>
+          </a:xfrm>
+          <a:prstGeom prst="rect">
+            <a:avLst/>
+          </a:prstGeom>
+          <a:noFill/>
+        </p:spPr>
+        <p:txBody>
+          <a:bodyPr wrap="square">
+            <a:spAutoFit/>
+          </a:bodyPr>
+          <a:lstStyle/>
+          <a:p>
+            <a:pPr algn="l"/>
+            <a:r>
+              <a:rPr sz="1000" b="1" i="0">
+                <a:solidFill>
+                  <a:srgbClr val="459BFF"/>
+                </a:solidFill>
+              </a:rPr>
+              <a:t>Cora  ·  Clean → 50% injection</a:t>
+            </a:r>
+          </a:p>
+        </p:txBody>
+      </p:sp>
+      <p:sp>
+        <p:nvSpPr>
+          <p:cNvPr id="12" name="Rectangle 11"/>
+          <p:cNvSpPr/>
+          <p:nvPr/>
+        </p:nvSpPr>
+        <p:spPr>
+          <a:xfrm>
+            <a:off x="8823960" y="1865376"/>
+            <a:ext cx="3108960" cy="292608"/>
+          </a:xfrm>
+          <a:prstGeom prst="rect">
+            <a:avLst/>
+          </a:prstGeom>
+          <a:solidFill>
+            <a:srgbClr val="1E222C"/>
+          </a:solidFill>
+          <a:ln>
+            <a:noFill/>
+          </a:ln>
+        </p:spPr>
+        <p:style>
+          <a:lnRef idx="1">
+            <a:schemeClr val="accent1"/>
+          </a:lnRef>
+          <a:fillRef idx="3">
+            <a:schemeClr val="accent1"/>
+          </a:fillRef>
+          <a:effectRef idx="2">
+            <a:schemeClr val="accent1"/>
+          </a:effectRef>
+          <a:fontRef idx="minor">
+            <a:schemeClr val="lt1"/>
+          </a:fontRef>
+        </p:style>
+        <p:txBody>
+          <a:bodyPr rtlCol="0" anchor="ctr"/>
+          <a:lstStyle/>
+          <a:p>
+            <a:pPr algn="ctr"/>
+          </a:p>
+        </p:txBody>
+      </p:sp>
+      <p:sp>
+        <p:nvSpPr>
+          <p:cNvPr id="13" name="TextBox 12"/>
+          <p:cNvSpPr txBox="1"/>
+          <p:nvPr/>
+        </p:nvSpPr>
+        <p:spPr>
+          <a:xfrm>
+            <a:off x="8897112" y="1901952"/>
+            <a:ext cx="914400" cy="292608"/>
+          </a:xfrm>
+          <a:prstGeom prst="rect">
+            <a:avLst/>
+          </a:prstGeom>
+          <a:noFill/>
+        </p:spPr>
+        <p:txBody>
+          <a:bodyPr wrap="square">
+            <a:spAutoFit/>
+          </a:bodyPr>
+          <a:lstStyle/>
+          <a:p>
+            <a:pPr algn="l"/>
+            <a:r>
+              <a:rPr sz="1000" b="0" i="0">
                 <a:solidFill>
                   <a:srgbClr val="8A93A8"/>
                 </a:solidFill>
               </a:rPr>
-              <a:t>[Sweep still running — re-run script after /tmp/sweep_results.json is written]</a:t>
+              <a:t>GraphSAGE</a:t>
+            </a:r>
+          </a:p>
+        </p:txBody>
+      </p:sp>
+      <p:sp>
+        <p:nvSpPr>
+          <p:cNvPr id="14" name="TextBox 13"/>
+          <p:cNvSpPr txBox="1"/>
+          <p:nvPr/>
+        </p:nvSpPr>
+        <p:spPr>
+          <a:xfrm>
+            <a:off x="9848088" y="1901952"/>
+            <a:ext cx="1234440" cy="292608"/>
+          </a:xfrm>
+          <a:prstGeom prst="rect">
+            <a:avLst/>
+          </a:prstGeom>
+          <a:noFill/>
+        </p:spPr>
+        <p:txBody>
+          <a:bodyPr wrap="square">
+            <a:spAutoFit/>
+          </a:bodyPr>
+          <a:lstStyle/>
+          <a:p>
+            <a:pPr algn="ctr"/>
+            <a:r>
+              <a:rPr sz="1000" b="0" i="0">
+                <a:solidFill>
+                  <a:srgbClr val="FFFFFF"/>
+                </a:solidFill>
+              </a:rPr>
+              <a:t>78.7 → 71.8</a:t>
+            </a:r>
+          </a:p>
+        </p:txBody>
+      </p:sp>
+      <p:sp>
+        <p:nvSpPr>
+          <p:cNvPr id="15" name="TextBox 14"/>
+          <p:cNvSpPr txBox="1"/>
+          <p:nvPr/>
+        </p:nvSpPr>
+        <p:spPr>
+          <a:xfrm>
+            <a:off x="11109960" y="1901952"/>
+            <a:ext cx="777240" cy="292608"/>
+          </a:xfrm>
+          <a:prstGeom prst="rect">
+            <a:avLst/>
+          </a:prstGeom>
+          <a:noFill/>
+        </p:spPr>
+        <p:txBody>
+          <a:bodyPr wrap="square">
+            <a:spAutoFit/>
+          </a:bodyPr>
+          <a:lstStyle/>
+          <a:p>
+            <a:pPr algn="ctr"/>
+            <a:r>
+              <a:rPr sz="1000" b="1" i="0">
+                <a:solidFill>
+                  <a:srgbClr val="8A93A8"/>
+                </a:solidFill>
+              </a:rPr>
+              <a:t>-6.9 pp</a:t>
+            </a:r>
+          </a:p>
+        </p:txBody>
+      </p:sp>
+      <p:sp>
+        <p:nvSpPr>
+          <p:cNvPr id="16" name="Rectangle 15"/>
+          <p:cNvSpPr/>
+          <p:nvPr/>
+        </p:nvSpPr>
+        <p:spPr>
+          <a:xfrm>
+            <a:off x="8823960" y="2157984"/>
+            <a:ext cx="3108960" cy="292608"/>
+          </a:xfrm>
+          <a:prstGeom prst="rect">
+            <a:avLst/>
+          </a:prstGeom>
+          <a:solidFill>
+            <a:srgbClr val="181C28"/>
+          </a:solidFill>
+          <a:ln>
+            <a:noFill/>
+          </a:ln>
+        </p:spPr>
+        <p:style>
+          <a:lnRef idx="1">
+            <a:schemeClr val="accent1"/>
+          </a:lnRef>
+          <a:fillRef idx="3">
+            <a:schemeClr val="accent1"/>
+          </a:fillRef>
+          <a:effectRef idx="2">
+            <a:schemeClr val="accent1"/>
+          </a:effectRef>
+          <a:fontRef idx="minor">
+            <a:schemeClr val="lt1"/>
+          </a:fontRef>
+        </p:style>
+        <p:txBody>
+          <a:bodyPr rtlCol="0" anchor="ctr"/>
+          <a:lstStyle/>
+          <a:p>
+            <a:pPr algn="ctr"/>
+          </a:p>
+        </p:txBody>
+      </p:sp>
+      <p:sp>
+        <p:nvSpPr>
+          <p:cNvPr id="17" name="TextBox 16"/>
+          <p:cNvSpPr txBox="1"/>
+          <p:nvPr/>
+        </p:nvSpPr>
+        <p:spPr>
+          <a:xfrm>
+            <a:off x="8897112" y="2194560"/>
+            <a:ext cx="914400" cy="292608"/>
+          </a:xfrm>
+          <a:prstGeom prst="rect">
+            <a:avLst/>
+          </a:prstGeom>
+          <a:noFill/>
+        </p:spPr>
+        <p:txBody>
+          <a:bodyPr wrap="square">
+            <a:spAutoFit/>
+          </a:bodyPr>
+          <a:lstStyle/>
+          <a:p>
+            <a:pPr algn="l"/>
+            <a:r>
+              <a:rPr sz="1000" b="0" i="0">
+                <a:solidFill>
+                  <a:srgbClr val="FF4D4D"/>
+                </a:solidFill>
+              </a:rPr>
+              <a:t>A  Cosine</a:t>
+            </a:r>
+          </a:p>
+        </p:txBody>
+      </p:sp>
+      <p:sp>
+        <p:nvSpPr>
+          <p:cNvPr id="18" name="TextBox 17"/>
+          <p:cNvSpPr txBox="1"/>
+          <p:nvPr/>
+        </p:nvSpPr>
+        <p:spPr>
+          <a:xfrm>
+            <a:off x="9848088" y="2194560"/>
+            <a:ext cx="1234440" cy="292608"/>
+          </a:xfrm>
+          <a:prstGeom prst="rect">
+            <a:avLst/>
+          </a:prstGeom>
+          <a:noFill/>
+        </p:spPr>
+        <p:txBody>
+          <a:bodyPr wrap="square">
+            <a:spAutoFit/>
+          </a:bodyPr>
+          <a:lstStyle/>
+          <a:p>
+            <a:pPr algn="ctr"/>
+            <a:r>
+              <a:rPr sz="1000" b="0" i="0">
+                <a:solidFill>
+                  <a:srgbClr val="FFFFFF"/>
+                </a:solidFill>
+              </a:rPr>
+              <a:t>79.6 → 71.2</a:t>
+            </a:r>
+          </a:p>
+        </p:txBody>
+      </p:sp>
+      <p:sp>
+        <p:nvSpPr>
+          <p:cNvPr id="19" name="TextBox 18"/>
+          <p:cNvSpPr txBox="1"/>
+          <p:nvPr/>
+        </p:nvSpPr>
+        <p:spPr>
+          <a:xfrm>
+            <a:off x="11109960" y="2194560"/>
+            <a:ext cx="777240" cy="292608"/>
+          </a:xfrm>
+          <a:prstGeom prst="rect">
+            <a:avLst/>
+          </a:prstGeom>
+          <a:noFill/>
+        </p:spPr>
+        <p:txBody>
+          <a:bodyPr wrap="square">
+            <a:spAutoFit/>
+          </a:bodyPr>
+          <a:lstStyle/>
+          <a:p>
+            <a:pPr algn="ctr"/>
+            <a:r>
+              <a:rPr sz="1000" b="1" i="0">
+                <a:solidFill>
+                  <a:srgbClr val="FF4D4D"/>
+                </a:solidFill>
+              </a:rPr>
+              <a:t>-8.4 pp</a:t>
+            </a:r>
+          </a:p>
+        </p:txBody>
+      </p:sp>
+      <p:sp>
+        <p:nvSpPr>
+          <p:cNvPr id="20" name="Rectangle 19"/>
+          <p:cNvSpPr/>
+          <p:nvPr/>
+        </p:nvSpPr>
+        <p:spPr>
+          <a:xfrm>
+            <a:off x="8823960" y="2450592"/>
+            <a:ext cx="3108960" cy="292608"/>
+          </a:xfrm>
+          <a:prstGeom prst="rect">
+            <a:avLst/>
+          </a:prstGeom>
+          <a:solidFill>
+            <a:srgbClr val="1E222C"/>
+          </a:solidFill>
+          <a:ln>
+            <a:noFill/>
+          </a:ln>
+        </p:spPr>
+        <p:style>
+          <a:lnRef idx="1">
+            <a:schemeClr val="accent1"/>
+          </a:lnRef>
+          <a:fillRef idx="3">
+            <a:schemeClr val="accent1"/>
+          </a:fillRef>
+          <a:effectRef idx="2">
+            <a:schemeClr val="accent1"/>
+          </a:effectRef>
+          <a:fontRef idx="minor">
+            <a:schemeClr val="lt1"/>
+          </a:fontRef>
+        </p:style>
+        <p:txBody>
+          <a:bodyPr rtlCol="0" anchor="ctr"/>
+          <a:lstStyle/>
+          <a:p>
+            <a:pPr algn="ctr"/>
+          </a:p>
+        </p:txBody>
+      </p:sp>
+      <p:sp>
+        <p:nvSpPr>
+          <p:cNvPr id="21" name="TextBox 20"/>
+          <p:cNvSpPr txBox="1"/>
+          <p:nvPr/>
+        </p:nvSpPr>
+        <p:spPr>
+          <a:xfrm>
+            <a:off x="8897112" y="2487168"/>
+            <a:ext cx="914400" cy="292608"/>
+          </a:xfrm>
+          <a:prstGeom prst="rect">
+            <a:avLst/>
+          </a:prstGeom>
+          <a:noFill/>
+        </p:spPr>
+        <p:txBody>
+          <a:bodyPr wrap="square">
+            <a:spAutoFit/>
+          </a:bodyPr>
+          <a:lstStyle/>
+          <a:p>
+            <a:pPr algn="l"/>
+            <a:r>
+              <a:rPr sz="1000" b="0" i="0">
+                <a:solidFill>
+                  <a:srgbClr val="FF7F2A"/>
+                </a:solidFill>
+              </a:rPr>
+              <a:t>B  Conf.</a:t>
+            </a:r>
+          </a:p>
+        </p:txBody>
+      </p:sp>
+      <p:sp>
+        <p:nvSpPr>
+          <p:cNvPr id="22" name="TextBox 21"/>
+          <p:cNvSpPr txBox="1"/>
+          <p:nvPr/>
+        </p:nvSpPr>
+        <p:spPr>
+          <a:xfrm>
+            <a:off x="9848088" y="2487168"/>
+            <a:ext cx="1234440" cy="292608"/>
+          </a:xfrm>
+          <a:prstGeom prst="rect">
+            <a:avLst/>
+          </a:prstGeom>
+          <a:noFill/>
+        </p:spPr>
+        <p:txBody>
+          <a:bodyPr wrap="square">
+            <a:spAutoFit/>
+          </a:bodyPr>
+          <a:lstStyle/>
+          <a:p>
+            <a:pPr algn="ctr"/>
+            <a:r>
+              <a:rPr sz="1000" b="0" i="0">
+                <a:solidFill>
+                  <a:srgbClr val="FFFFFF"/>
+                </a:solidFill>
+              </a:rPr>
+              <a:t>71.3 → 67.8</a:t>
+            </a:r>
+          </a:p>
+        </p:txBody>
+      </p:sp>
+      <p:sp>
+        <p:nvSpPr>
+          <p:cNvPr id="23" name="TextBox 22"/>
+          <p:cNvSpPr txBox="1"/>
+          <p:nvPr/>
+        </p:nvSpPr>
+        <p:spPr>
+          <a:xfrm>
+            <a:off x="11109960" y="2487168"/>
+            <a:ext cx="777240" cy="292608"/>
+          </a:xfrm>
+          <a:prstGeom prst="rect">
+            <a:avLst/>
+          </a:prstGeom>
+          <a:noFill/>
+        </p:spPr>
+        <p:txBody>
+          <a:bodyPr wrap="square">
+            <a:spAutoFit/>
+          </a:bodyPr>
+          <a:lstStyle/>
+          <a:p>
+            <a:pPr algn="ctr"/>
+            <a:r>
+              <a:rPr sz="1000" b="1" i="0">
+                <a:solidFill>
+                  <a:srgbClr val="2ECC71"/>
+                </a:solidFill>
+              </a:rPr>
+              <a:t>-3.6 pp</a:t>
+            </a:r>
+          </a:p>
+        </p:txBody>
+      </p:sp>
+      <p:sp>
+        <p:nvSpPr>
+          <p:cNvPr id="24" name="Rectangle 23"/>
+          <p:cNvSpPr/>
+          <p:nvPr/>
+        </p:nvSpPr>
+        <p:spPr>
+          <a:xfrm>
+            <a:off x="8823960" y="2743200"/>
+            <a:ext cx="3108960" cy="292608"/>
+          </a:xfrm>
+          <a:prstGeom prst="rect">
+            <a:avLst/>
+          </a:prstGeom>
+          <a:solidFill>
+            <a:srgbClr val="181C28"/>
+          </a:solidFill>
+          <a:ln>
+            <a:noFill/>
+          </a:ln>
+        </p:spPr>
+        <p:style>
+          <a:lnRef idx="1">
+            <a:schemeClr val="accent1"/>
+          </a:lnRef>
+          <a:fillRef idx="3">
+            <a:schemeClr val="accent1"/>
+          </a:fillRef>
+          <a:effectRef idx="2">
+            <a:schemeClr val="accent1"/>
+          </a:effectRef>
+          <a:fontRef idx="minor">
+            <a:schemeClr val="lt1"/>
+          </a:fontRef>
+        </p:style>
+        <p:txBody>
+          <a:bodyPr rtlCol="0" anchor="ctr"/>
+          <a:lstStyle/>
+          <a:p>
+            <a:pPr algn="ctr"/>
+          </a:p>
+        </p:txBody>
+      </p:sp>
+      <p:sp>
+        <p:nvSpPr>
+          <p:cNvPr id="25" name="TextBox 24"/>
+          <p:cNvSpPr txBox="1"/>
+          <p:nvPr/>
+        </p:nvSpPr>
+        <p:spPr>
+          <a:xfrm>
+            <a:off x="8897112" y="2779776"/>
+            <a:ext cx="914400" cy="292608"/>
+          </a:xfrm>
+          <a:prstGeom prst="rect">
+            <a:avLst/>
+          </a:prstGeom>
+          <a:noFill/>
+        </p:spPr>
+        <p:txBody>
+          <a:bodyPr wrap="square">
+            <a:spAutoFit/>
+          </a:bodyPr>
+          <a:lstStyle/>
+          <a:p>
+            <a:pPr algn="l"/>
+            <a:r>
+              <a:rPr sz="1000" b="0" i="0">
+                <a:solidFill>
+                  <a:srgbClr val="A06CFF"/>
+                </a:solidFill>
+              </a:rPr>
+              <a:t>C  Learned</a:t>
+            </a:r>
+          </a:p>
+        </p:txBody>
+      </p:sp>
+      <p:sp>
+        <p:nvSpPr>
+          <p:cNvPr id="26" name="TextBox 25"/>
+          <p:cNvSpPr txBox="1"/>
+          <p:nvPr/>
+        </p:nvSpPr>
+        <p:spPr>
+          <a:xfrm>
+            <a:off x="9848088" y="2779776"/>
+            <a:ext cx="1234440" cy="292608"/>
+          </a:xfrm>
+          <a:prstGeom prst="rect">
+            <a:avLst/>
+          </a:prstGeom>
+          <a:noFill/>
+        </p:spPr>
+        <p:txBody>
+          <a:bodyPr wrap="square">
+            <a:spAutoFit/>
+          </a:bodyPr>
+          <a:lstStyle/>
+          <a:p>
+            <a:pPr algn="ctr"/>
+            <a:r>
+              <a:rPr sz="1000" b="0" i="0">
+                <a:solidFill>
+                  <a:srgbClr val="FFFFFF"/>
+                </a:solidFill>
+              </a:rPr>
+              <a:t>71.6 → 65.7</a:t>
+            </a:r>
+          </a:p>
+        </p:txBody>
+      </p:sp>
+      <p:sp>
+        <p:nvSpPr>
+          <p:cNvPr id="27" name="TextBox 26"/>
+          <p:cNvSpPr txBox="1"/>
+          <p:nvPr/>
+        </p:nvSpPr>
+        <p:spPr>
+          <a:xfrm>
+            <a:off x="11109960" y="2779776"/>
+            <a:ext cx="777240" cy="292608"/>
+          </a:xfrm>
+          <a:prstGeom prst="rect">
+            <a:avLst/>
+          </a:prstGeom>
+          <a:noFill/>
+        </p:spPr>
+        <p:txBody>
+          <a:bodyPr wrap="square">
+            <a:spAutoFit/>
+          </a:bodyPr>
+          <a:lstStyle/>
+          <a:p>
+            <a:pPr algn="ctr"/>
+            <a:r>
+              <a:rPr sz="1000" b="1" i="0">
+                <a:solidFill>
+                  <a:srgbClr val="8A93A8"/>
+                </a:solidFill>
+              </a:rPr>
+              <a:t>-5.9 pp</a:t>
+            </a:r>
+          </a:p>
+        </p:txBody>
+      </p:sp>
+      <p:sp>
+        <p:nvSpPr>
+          <p:cNvPr id="28" name="Rectangle 27"/>
+          <p:cNvSpPr/>
+          <p:nvPr/>
+        </p:nvSpPr>
+        <p:spPr>
+          <a:xfrm>
+            <a:off x="8823960" y="3035808"/>
+            <a:ext cx="3108960" cy="292608"/>
+          </a:xfrm>
+          <a:prstGeom prst="rect">
+            <a:avLst/>
+          </a:prstGeom>
+          <a:solidFill>
+            <a:srgbClr val="1A263A"/>
+          </a:solidFill>
+          <a:ln>
+            <a:noFill/>
+          </a:ln>
+        </p:spPr>
+        <p:style>
+          <a:lnRef idx="1">
+            <a:schemeClr val="accent1"/>
+          </a:lnRef>
+          <a:fillRef idx="3">
+            <a:schemeClr val="accent1"/>
+          </a:fillRef>
+          <a:effectRef idx="2">
+            <a:schemeClr val="accent1"/>
+          </a:effectRef>
+          <a:fontRef idx="minor">
+            <a:schemeClr val="lt1"/>
+          </a:fontRef>
+        </p:style>
+        <p:txBody>
+          <a:bodyPr rtlCol="0" anchor="ctr"/>
+          <a:lstStyle/>
+          <a:p>
+            <a:pPr algn="ctr"/>
+          </a:p>
+        </p:txBody>
+      </p:sp>
+      <p:sp>
+        <p:nvSpPr>
+          <p:cNvPr id="29" name="TextBox 28"/>
+          <p:cNvSpPr txBox="1"/>
+          <p:nvPr/>
+        </p:nvSpPr>
+        <p:spPr>
+          <a:xfrm>
+            <a:off x="8897112" y="3072384"/>
+            <a:ext cx="914400" cy="292608"/>
+          </a:xfrm>
+          <a:prstGeom prst="rect">
+            <a:avLst/>
+          </a:prstGeom>
+          <a:noFill/>
+        </p:spPr>
+        <p:txBody>
+          <a:bodyPr wrap="square">
+            <a:spAutoFit/>
+          </a:bodyPr>
+          <a:lstStyle/>
+          <a:p>
+            <a:pPr algn="l"/>
+            <a:r>
+              <a:rPr sz="1000" b="1" i="0">
+                <a:solidFill>
+                  <a:srgbClr val="45C4FF"/>
+                </a:solidFill>
+              </a:rPr>
+              <a:t>D  LLM</a:t>
+            </a:r>
+          </a:p>
+        </p:txBody>
+      </p:sp>
+      <p:sp>
+        <p:nvSpPr>
+          <p:cNvPr id="30" name="TextBox 29"/>
+          <p:cNvSpPr txBox="1"/>
+          <p:nvPr/>
+        </p:nvSpPr>
+        <p:spPr>
+          <a:xfrm>
+            <a:off x="9848088" y="3072384"/>
+            <a:ext cx="1234440" cy="292608"/>
+          </a:xfrm>
+          <a:prstGeom prst="rect">
+            <a:avLst/>
+          </a:prstGeom>
+          <a:noFill/>
+        </p:spPr>
+        <p:txBody>
+          <a:bodyPr wrap="square">
+            <a:spAutoFit/>
+          </a:bodyPr>
+          <a:lstStyle/>
+          <a:p>
+            <a:pPr algn="ctr"/>
+            <a:r>
+              <a:rPr sz="1000" b="0" i="0">
+                <a:solidFill>
+                  <a:srgbClr val="FFFFFF"/>
+                </a:solidFill>
+              </a:rPr>
+              <a:t>79.6 → 71.2</a:t>
+            </a:r>
+          </a:p>
+        </p:txBody>
+      </p:sp>
+      <p:sp>
+        <p:nvSpPr>
+          <p:cNvPr id="31" name="TextBox 30"/>
+          <p:cNvSpPr txBox="1"/>
+          <p:nvPr/>
+        </p:nvSpPr>
+        <p:spPr>
+          <a:xfrm>
+            <a:off x="11109960" y="3072384"/>
+            <a:ext cx="777240" cy="292608"/>
+          </a:xfrm>
+          <a:prstGeom prst="rect">
+            <a:avLst/>
+          </a:prstGeom>
+          <a:noFill/>
+        </p:spPr>
+        <p:txBody>
+          <a:bodyPr wrap="square">
+            <a:spAutoFit/>
+          </a:bodyPr>
+          <a:lstStyle/>
+          <a:p>
+            <a:pPr algn="ctr"/>
+            <a:r>
+              <a:rPr sz="1000" b="1" i="0">
+                <a:solidFill>
+                  <a:srgbClr val="FF4D4D"/>
+                </a:solidFill>
+              </a:rPr>
+              <a:t>-8.4 pp</a:t>
+            </a:r>
+          </a:p>
+        </p:txBody>
+      </p:sp>
+      <p:sp>
+        <p:nvSpPr>
+          <p:cNvPr id="32" name="Rectangle 31"/>
+          <p:cNvSpPr/>
+          <p:nvPr/>
+        </p:nvSpPr>
+        <p:spPr>
+          <a:xfrm>
+            <a:off x="8823960" y="3401568"/>
+            <a:ext cx="3108960" cy="256032"/>
+          </a:xfrm>
+          <a:prstGeom prst="rect">
+            <a:avLst/>
+          </a:prstGeom>
+          <a:solidFill>
+            <a:srgbClr val="161C2C"/>
+          </a:solidFill>
+          <a:ln>
+            <a:noFill/>
+          </a:ln>
+        </p:spPr>
+        <p:style>
+          <a:lnRef idx="1">
+            <a:schemeClr val="accent1"/>
+          </a:lnRef>
+          <a:fillRef idx="3">
+            <a:schemeClr val="accent1"/>
+          </a:fillRef>
+          <a:effectRef idx="2">
+            <a:schemeClr val="accent1"/>
+          </a:effectRef>
+          <a:fontRef idx="minor">
+            <a:schemeClr val="lt1"/>
+          </a:fontRef>
+        </p:style>
+        <p:txBody>
+          <a:bodyPr rtlCol="0" anchor="ctr"/>
+          <a:lstStyle/>
+          <a:p>
+            <a:pPr algn="ctr"/>
+          </a:p>
+        </p:txBody>
+      </p:sp>
+      <p:sp>
+        <p:nvSpPr>
+          <p:cNvPr id="33" name="TextBox 32"/>
+          <p:cNvSpPr txBox="1"/>
+          <p:nvPr/>
+        </p:nvSpPr>
+        <p:spPr>
+          <a:xfrm>
+            <a:off x="8897112" y="3419856"/>
+            <a:ext cx="3063240" cy="228600"/>
+          </a:xfrm>
+          <a:prstGeom prst="rect">
+            <a:avLst/>
+          </a:prstGeom>
+          <a:noFill/>
+        </p:spPr>
+        <p:txBody>
+          <a:bodyPr wrap="square">
+            <a:spAutoFit/>
+          </a:bodyPr>
+          <a:lstStyle/>
+          <a:p>
+            <a:pPr algn="l"/>
+            <a:r>
+              <a:rPr sz="1000" b="1" i="0">
+                <a:solidFill>
+                  <a:srgbClr val="FF7F2A"/>
+                </a:solidFill>
+              </a:rPr>
+              <a:t>Texas  ·  Heterophily (h=0.31)</a:t>
+            </a:r>
+          </a:p>
+        </p:txBody>
+      </p:sp>
+      <p:sp>
+        <p:nvSpPr>
+          <p:cNvPr id="34" name="Rectangle 33"/>
+          <p:cNvSpPr/>
+          <p:nvPr/>
+        </p:nvSpPr>
+        <p:spPr>
+          <a:xfrm>
+            <a:off x="8823960" y="3675888"/>
+            <a:ext cx="3108960" cy="292608"/>
+          </a:xfrm>
+          <a:prstGeom prst="rect">
+            <a:avLst/>
+          </a:prstGeom>
+          <a:solidFill>
+            <a:srgbClr val="1E222C"/>
+          </a:solidFill>
+          <a:ln>
+            <a:noFill/>
+          </a:ln>
+        </p:spPr>
+        <p:style>
+          <a:lnRef idx="1">
+            <a:schemeClr val="accent1"/>
+          </a:lnRef>
+          <a:fillRef idx="3">
+            <a:schemeClr val="accent1"/>
+          </a:fillRef>
+          <a:effectRef idx="2">
+            <a:schemeClr val="accent1"/>
+          </a:effectRef>
+          <a:fontRef idx="minor">
+            <a:schemeClr val="lt1"/>
+          </a:fontRef>
+        </p:style>
+        <p:txBody>
+          <a:bodyPr rtlCol="0" anchor="ctr"/>
+          <a:lstStyle/>
+          <a:p>
+            <a:pPr algn="ctr"/>
+          </a:p>
+        </p:txBody>
+      </p:sp>
+      <p:sp>
+        <p:nvSpPr>
+          <p:cNvPr id="35" name="TextBox 34"/>
+          <p:cNvSpPr txBox="1"/>
+          <p:nvPr/>
+        </p:nvSpPr>
+        <p:spPr>
+          <a:xfrm>
+            <a:off x="8897112" y="3712464"/>
+            <a:ext cx="1280160" cy="292608"/>
+          </a:xfrm>
+          <a:prstGeom prst="rect">
+            <a:avLst/>
+          </a:prstGeom>
+          <a:noFill/>
+        </p:spPr>
+        <p:txBody>
+          <a:bodyPr wrap="square">
+            <a:spAutoFit/>
+          </a:bodyPr>
+          <a:lstStyle/>
+          <a:p>
+            <a:pPr algn="l"/>
+            <a:r>
+              <a:rPr sz="1000" b="0" i="0">
+                <a:solidFill>
+                  <a:srgbClr val="8A93A8"/>
+                </a:solidFill>
+              </a:rPr>
+              <a:t>GraphSAGE</a:t>
+            </a:r>
+          </a:p>
+        </p:txBody>
+      </p:sp>
+      <p:sp>
+        <p:nvSpPr>
+          <p:cNvPr id="36" name="TextBox 35"/>
+          <p:cNvSpPr txBox="1"/>
+          <p:nvPr/>
+        </p:nvSpPr>
+        <p:spPr>
+          <a:xfrm>
+            <a:off x="11109960" y="3712464"/>
+            <a:ext cx="777240" cy="292608"/>
+          </a:xfrm>
+          <a:prstGeom prst="rect">
+            <a:avLst/>
+          </a:prstGeom>
+          <a:noFill/>
+        </p:spPr>
+        <p:txBody>
+          <a:bodyPr wrap="square">
+            <a:spAutoFit/>
+          </a:bodyPr>
+          <a:lstStyle/>
+          <a:p>
+            <a:pPr algn="ctr"/>
+            <a:r>
+              <a:rPr sz="1000" b="1" i="0">
+                <a:solidFill>
+                  <a:srgbClr val="8A93A8"/>
+                </a:solidFill>
+              </a:rPr>
+              <a:t>76.6%</a:t>
+            </a:r>
+          </a:p>
+        </p:txBody>
+      </p:sp>
+      <p:sp>
+        <p:nvSpPr>
+          <p:cNvPr id="37" name="Rectangle 36"/>
+          <p:cNvSpPr/>
+          <p:nvPr/>
+        </p:nvSpPr>
+        <p:spPr>
+          <a:xfrm>
+            <a:off x="8823960" y="3968496"/>
+            <a:ext cx="3108960" cy="292608"/>
+          </a:xfrm>
+          <a:prstGeom prst="rect">
+            <a:avLst/>
+          </a:prstGeom>
+          <a:solidFill>
+            <a:srgbClr val="181C28"/>
+          </a:solidFill>
+          <a:ln>
+            <a:noFill/>
+          </a:ln>
+        </p:spPr>
+        <p:style>
+          <a:lnRef idx="1">
+            <a:schemeClr val="accent1"/>
+          </a:lnRef>
+          <a:fillRef idx="3">
+            <a:schemeClr val="accent1"/>
+          </a:fillRef>
+          <a:effectRef idx="2">
+            <a:schemeClr val="accent1"/>
+          </a:effectRef>
+          <a:fontRef idx="minor">
+            <a:schemeClr val="lt1"/>
+          </a:fontRef>
+        </p:style>
+        <p:txBody>
+          <a:bodyPr rtlCol="0" anchor="ctr"/>
+          <a:lstStyle/>
+          <a:p>
+            <a:pPr algn="ctr"/>
+          </a:p>
+        </p:txBody>
+      </p:sp>
+      <p:sp>
+        <p:nvSpPr>
+          <p:cNvPr id="38" name="TextBox 37"/>
+          <p:cNvSpPr txBox="1"/>
+          <p:nvPr/>
+        </p:nvSpPr>
+        <p:spPr>
+          <a:xfrm>
+            <a:off x="8897112" y="4005072"/>
+            <a:ext cx="1280160" cy="292608"/>
+          </a:xfrm>
+          <a:prstGeom prst="rect">
+            <a:avLst/>
+          </a:prstGeom>
+          <a:noFill/>
+        </p:spPr>
+        <p:txBody>
+          <a:bodyPr wrap="square">
+            <a:spAutoFit/>
+          </a:bodyPr>
+          <a:lstStyle/>
+          <a:p>
+            <a:pPr algn="l"/>
+            <a:r>
+              <a:rPr sz="1000" b="0" i="0">
+                <a:solidFill>
+                  <a:srgbClr val="FF4D4D"/>
+                </a:solidFill>
+              </a:rPr>
+              <a:t>A  Cosine</a:t>
+            </a:r>
+          </a:p>
+        </p:txBody>
+      </p:sp>
+      <p:sp>
+        <p:nvSpPr>
+          <p:cNvPr id="39" name="TextBox 38"/>
+          <p:cNvSpPr txBox="1"/>
+          <p:nvPr/>
+        </p:nvSpPr>
+        <p:spPr>
+          <a:xfrm>
+            <a:off x="11109960" y="4005072"/>
+            <a:ext cx="777240" cy="292608"/>
+          </a:xfrm>
+          <a:prstGeom prst="rect">
+            <a:avLst/>
+          </a:prstGeom>
+          <a:noFill/>
+        </p:spPr>
+        <p:txBody>
+          <a:bodyPr wrap="square">
+            <a:spAutoFit/>
+          </a:bodyPr>
+          <a:lstStyle/>
+          <a:p>
+            <a:pPr algn="ctr"/>
+            <a:r>
+              <a:rPr sz="1000" b="1" i="0">
+                <a:solidFill>
+                  <a:srgbClr val="FF4D4D"/>
+                </a:solidFill>
+              </a:rPr>
+              <a:t>58.6%</a:t>
+            </a:r>
+          </a:p>
+        </p:txBody>
+      </p:sp>
+      <p:sp>
+        <p:nvSpPr>
+          <p:cNvPr id="40" name="Rectangle 39"/>
+          <p:cNvSpPr/>
+          <p:nvPr/>
+        </p:nvSpPr>
+        <p:spPr>
+          <a:xfrm>
+            <a:off x="8823960" y="4261104"/>
+            <a:ext cx="3108960" cy="292608"/>
+          </a:xfrm>
+          <a:prstGeom prst="rect">
+            <a:avLst/>
+          </a:prstGeom>
+          <a:solidFill>
+            <a:srgbClr val="1E222C"/>
+          </a:solidFill>
+          <a:ln>
+            <a:noFill/>
+          </a:ln>
+        </p:spPr>
+        <p:style>
+          <a:lnRef idx="1">
+            <a:schemeClr val="accent1"/>
+          </a:lnRef>
+          <a:fillRef idx="3">
+            <a:schemeClr val="accent1"/>
+          </a:fillRef>
+          <a:effectRef idx="2">
+            <a:schemeClr val="accent1"/>
+          </a:effectRef>
+          <a:fontRef idx="minor">
+            <a:schemeClr val="lt1"/>
+          </a:fontRef>
+        </p:style>
+        <p:txBody>
+          <a:bodyPr rtlCol="0" anchor="ctr"/>
+          <a:lstStyle/>
+          <a:p>
+            <a:pPr algn="ctr"/>
+          </a:p>
+        </p:txBody>
+      </p:sp>
+      <p:sp>
+        <p:nvSpPr>
+          <p:cNvPr id="41" name="TextBox 40"/>
+          <p:cNvSpPr txBox="1"/>
+          <p:nvPr/>
+        </p:nvSpPr>
+        <p:spPr>
+          <a:xfrm>
+            <a:off x="8897112" y="4297680"/>
+            <a:ext cx="1280160" cy="292608"/>
+          </a:xfrm>
+          <a:prstGeom prst="rect">
+            <a:avLst/>
+          </a:prstGeom>
+          <a:noFill/>
+        </p:spPr>
+        <p:txBody>
+          <a:bodyPr wrap="square">
+            <a:spAutoFit/>
+          </a:bodyPr>
+          <a:lstStyle/>
+          <a:p>
+            <a:pPr algn="l"/>
+            <a:r>
+              <a:rPr sz="1000" b="0" i="0">
+                <a:solidFill>
+                  <a:srgbClr val="FF7F2A"/>
+                </a:solidFill>
+              </a:rPr>
+              <a:t>B  Conf.</a:t>
+            </a:r>
+          </a:p>
+        </p:txBody>
+      </p:sp>
+      <p:sp>
+        <p:nvSpPr>
+          <p:cNvPr id="42" name="TextBox 41"/>
+          <p:cNvSpPr txBox="1"/>
+          <p:nvPr/>
+        </p:nvSpPr>
+        <p:spPr>
+          <a:xfrm>
+            <a:off x="11109960" y="4297680"/>
+            <a:ext cx="777240" cy="292608"/>
+          </a:xfrm>
+          <a:prstGeom prst="rect">
+            <a:avLst/>
+          </a:prstGeom>
+          <a:noFill/>
+        </p:spPr>
+        <p:txBody>
+          <a:bodyPr wrap="square">
+            <a:spAutoFit/>
+          </a:bodyPr>
+          <a:lstStyle/>
+          <a:p>
+            <a:pPr algn="ctr"/>
+            <a:r>
+              <a:rPr sz="1000" b="1" i="0">
+                <a:solidFill>
+                  <a:srgbClr val="2ECC71"/>
+                </a:solidFill>
+              </a:rPr>
+              <a:t>81.1%</a:t>
+            </a:r>
+          </a:p>
+        </p:txBody>
+      </p:sp>
+      <p:sp>
+        <p:nvSpPr>
+          <p:cNvPr id="43" name="Rectangle 42"/>
+          <p:cNvSpPr/>
+          <p:nvPr/>
+        </p:nvSpPr>
+        <p:spPr>
+          <a:xfrm>
+            <a:off x="8823960" y="4553712"/>
+            <a:ext cx="3108960" cy="292608"/>
+          </a:xfrm>
+          <a:prstGeom prst="rect">
+            <a:avLst/>
+          </a:prstGeom>
+          <a:solidFill>
+            <a:srgbClr val="181C28"/>
+          </a:solidFill>
+          <a:ln>
+            <a:noFill/>
+          </a:ln>
+        </p:spPr>
+        <p:style>
+          <a:lnRef idx="1">
+            <a:schemeClr val="accent1"/>
+          </a:lnRef>
+          <a:fillRef idx="3">
+            <a:schemeClr val="accent1"/>
+          </a:fillRef>
+          <a:effectRef idx="2">
+            <a:schemeClr val="accent1"/>
+          </a:effectRef>
+          <a:fontRef idx="minor">
+            <a:schemeClr val="lt1"/>
+          </a:fontRef>
+        </p:style>
+        <p:txBody>
+          <a:bodyPr rtlCol="0" anchor="ctr"/>
+          <a:lstStyle/>
+          <a:p>
+            <a:pPr algn="ctr"/>
+          </a:p>
+        </p:txBody>
+      </p:sp>
+      <p:sp>
+        <p:nvSpPr>
+          <p:cNvPr id="44" name="TextBox 43"/>
+          <p:cNvSpPr txBox="1"/>
+          <p:nvPr/>
+        </p:nvSpPr>
+        <p:spPr>
+          <a:xfrm>
+            <a:off x="8897112" y="4590288"/>
+            <a:ext cx="1280160" cy="292608"/>
+          </a:xfrm>
+          <a:prstGeom prst="rect">
+            <a:avLst/>
+          </a:prstGeom>
+          <a:noFill/>
+        </p:spPr>
+        <p:txBody>
+          <a:bodyPr wrap="square">
+            <a:spAutoFit/>
+          </a:bodyPr>
+          <a:lstStyle/>
+          <a:p>
+            <a:pPr algn="l"/>
+            <a:r>
+              <a:rPr sz="1000" b="0" i="0">
+                <a:solidFill>
+                  <a:srgbClr val="A06CFF"/>
+                </a:solidFill>
+              </a:rPr>
+              <a:t>C  Learned</a:t>
+            </a:r>
+          </a:p>
+        </p:txBody>
+      </p:sp>
+      <p:sp>
+        <p:nvSpPr>
+          <p:cNvPr id="45" name="TextBox 44"/>
+          <p:cNvSpPr txBox="1"/>
+          <p:nvPr/>
+        </p:nvSpPr>
+        <p:spPr>
+          <a:xfrm>
+            <a:off x="11109960" y="4590288"/>
+            <a:ext cx="777240" cy="292608"/>
+          </a:xfrm>
+          <a:prstGeom prst="rect">
+            <a:avLst/>
+          </a:prstGeom>
+          <a:noFill/>
+        </p:spPr>
+        <p:txBody>
+          <a:bodyPr wrap="square">
+            <a:spAutoFit/>
+          </a:bodyPr>
+          <a:lstStyle/>
+          <a:p>
+            <a:pPr algn="ctr"/>
+            <a:r>
+              <a:rPr sz="1000" b="1" i="0">
+                <a:solidFill>
+                  <a:srgbClr val="2ECC71"/>
+                </a:solidFill>
+              </a:rPr>
+              <a:t>81.1%</a:t>
+            </a:r>
+          </a:p>
+        </p:txBody>
+      </p:sp>
+      <p:sp>
+        <p:nvSpPr>
+          <p:cNvPr id="46" name="Rectangle 45"/>
+          <p:cNvSpPr/>
+          <p:nvPr/>
+        </p:nvSpPr>
+        <p:spPr>
+          <a:xfrm>
+            <a:off x="8823960" y="4846320"/>
+            <a:ext cx="3108960" cy="292608"/>
+          </a:xfrm>
+          <a:prstGeom prst="rect">
+            <a:avLst/>
+          </a:prstGeom>
+          <a:solidFill>
+            <a:srgbClr val="1A263A"/>
+          </a:solidFill>
+          <a:ln>
+            <a:noFill/>
+          </a:ln>
+        </p:spPr>
+        <p:style>
+          <a:lnRef idx="1">
+            <a:schemeClr val="accent1"/>
+          </a:lnRef>
+          <a:fillRef idx="3">
+            <a:schemeClr val="accent1"/>
+          </a:fillRef>
+          <a:effectRef idx="2">
+            <a:schemeClr val="accent1"/>
+          </a:effectRef>
+          <a:fontRef idx="minor">
+            <a:schemeClr val="lt1"/>
+          </a:fontRef>
+        </p:style>
+        <p:txBody>
+          <a:bodyPr rtlCol="0" anchor="ctr"/>
+          <a:lstStyle/>
+          <a:p>
+            <a:pPr algn="ctr"/>
+          </a:p>
+        </p:txBody>
+      </p:sp>
+      <p:sp>
+        <p:nvSpPr>
+          <p:cNvPr id="47" name="TextBox 46"/>
+          <p:cNvSpPr txBox="1"/>
+          <p:nvPr/>
+        </p:nvSpPr>
+        <p:spPr>
+          <a:xfrm>
+            <a:off x="8897112" y="4882896"/>
+            <a:ext cx="1280160" cy="292608"/>
+          </a:xfrm>
+          <a:prstGeom prst="rect">
+            <a:avLst/>
+          </a:prstGeom>
+          <a:noFill/>
+        </p:spPr>
+        <p:txBody>
+          <a:bodyPr wrap="square">
+            <a:spAutoFit/>
+          </a:bodyPr>
+          <a:lstStyle/>
+          <a:p>
+            <a:pPr algn="l"/>
+            <a:r>
+              <a:rPr sz="1000" b="1" i="0">
+                <a:solidFill>
+                  <a:srgbClr val="45C4FF"/>
+                </a:solidFill>
+              </a:rPr>
+              <a:t>D  LLM</a:t>
+            </a:r>
+          </a:p>
+        </p:txBody>
+      </p:sp>
+      <p:sp>
+        <p:nvSpPr>
+          <p:cNvPr id="48" name="TextBox 47"/>
+          <p:cNvSpPr txBox="1"/>
+          <p:nvPr/>
+        </p:nvSpPr>
+        <p:spPr>
+          <a:xfrm>
+            <a:off x="11109960" y="4882896"/>
+            <a:ext cx="777240" cy="292608"/>
+          </a:xfrm>
+          <a:prstGeom prst="rect">
+            <a:avLst/>
+          </a:prstGeom>
+          <a:noFill/>
+        </p:spPr>
+        <p:txBody>
+          <a:bodyPr wrap="square">
+            <a:spAutoFit/>
+          </a:bodyPr>
+          <a:lstStyle/>
+          <a:p>
+            <a:pPr algn="ctr"/>
+            <a:r>
+              <a:rPr sz="1000" b="1" i="0">
+                <a:solidFill>
+                  <a:srgbClr val="FF4D4D"/>
+                </a:solidFill>
+              </a:rPr>
+              <a:t>60.4%</a:t>
+            </a:r>
+          </a:p>
+        </p:txBody>
+      </p:sp>
+      <p:sp>
+        <p:nvSpPr>
+          <p:cNvPr id="49" name="Rectangle 48"/>
+          <p:cNvSpPr/>
+          <p:nvPr/>
+        </p:nvSpPr>
+        <p:spPr>
+          <a:xfrm>
+            <a:off x="502920" y="4370832"/>
+            <a:ext cx="11201400" cy="2286000"/>
+          </a:xfrm>
+          <a:prstGeom prst="rect">
+            <a:avLst/>
+          </a:prstGeom>
+          <a:solidFill>
+            <a:srgbClr val="101420"/>
+          </a:solidFill>
+          <a:ln w="10160">
+            <a:solidFill>
+              <a:srgbClr val="353C50"/>
+            </a:solidFill>
+          </a:ln>
+        </p:spPr>
+        <p:style>
+          <a:lnRef idx="1">
+            <a:schemeClr val="accent1"/>
+          </a:lnRef>
+          <a:fillRef idx="3">
+            <a:schemeClr val="accent1"/>
+          </a:fillRef>
+          <a:effectRef idx="2">
+            <a:schemeClr val="accent1"/>
+          </a:effectRef>
+          <a:fontRef idx="minor">
+            <a:schemeClr val="lt1"/>
+          </a:fontRef>
+        </p:style>
+        <p:txBody>
+          <a:bodyPr rtlCol="0" anchor="ctr"/>
+          <a:lstStyle/>
+          <a:p>
+            <a:pPr algn="ctr"/>
+          </a:p>
+        </p:txBody>
+      </p:sp>
+      <p:sp>
+        <p:nvSpPr>
+          <p:cNvPr id="50" name="TextBox 49"/>
+          <p:cNvSpPr txBox="1"/>
+          <p:nvPr/>
+        </p:nvSpPr>
+        <p:spPr>
+          <a:xfrm>
+            <a:off x="658368" y="4498848"/>
+            <a:ext cx="4572000" cy="347472"/>
+          </a:xfrm>
+          <a:prstGeom prst="rect">
+            <a:avLst/>
+          </a:prstGeom>
+          <a:noFill/>
+        </p:spPr>
+        <p:txBody>
+          <a:bodyPr wrap="square">
+            <a:spAutoFit/>
+          </a:bodyPr>
+          <a:lstStyle/>
+          <a:p>
+            <a:pPr algn="l"/>
+            <a:r>
+              <a:rPr sz="1400" b="1" i="0">
+                <a:solidFill>
+                  <a:srgbClr val="FFFFFF"/>
+                </a:solidFill>
+              </a:rPr>
+              <a:t>What the results show</a:t>
+            </a:r>
+          </a:p>
+        </p:txBody>
+      </p:sp>
+      <p:sp>
+        <p:nvSpPr>
+          <p:cNvPr id="51" name="TextBox 50"/>
+          <p:cNvSpPr txBox="1"/>
+          <p:nvPr/>
+        </p:nvSpPr>
+        <p:spPr>
+          <a:xfrm>
+            <a:off x="658368" y="4919472"/>
+            <a:ext cx="256032" cy="384048"/>
+          </a:xfrm>
+          <a:prstGeom prst="rect">
+            <a:avLst/>
+          </a:prstGeom>
+          <a:noFill/>
+        </p:spPr>
+        <p:txBody>
+          <a:bodyPr wrap="square">
+            <a:spAutoFit/>
+          </a:bodyPr>
+          <a:lstStyle/>
+          <a:p>
+            <a:pPr algn="l"/>
+            <a:r>
+              <a:rPr sz="1200" b="1" i="0">
+                <a:solidFill>
+                  <a:srgbClr val="FF7F2A"/>
+                </a:solidFill>
+              </a:rPr>
+              <a:t>▶</a:t>
+            </a:r>
+          </a:p>
+        </p:txBody>
+      </p:sp>
+      <p:sp>
+        <p:nvSpPr>
+          <p:cNvPr id="52" name="TextBox 51"/>
+          <p:cNvSpPr txBox="1"/>
+          <p:nvPr/>
+        </p:nvSpPr>
+        <p:spPr>
+          <a:xfrm>
+            <a:off x="960120" y="4919472"/>
+            <a:ext cx="10515600" cy="384048"/>
+          </a:xfrm>
+          <a:prstGeom prst="rect">
+            <a:avLst/>
+          </a:prstGeom>
+          <a:noFill/>
+        </p:spPr>
+        <p:txBody>
+          <a:bodyPr wrap="square">
+            <a:spAutoFit/>
+          </a:bodyPr>
+          <a:lstStyle/>
+          <a:p>
+            <a:pPr algn="l"/>
+            <a:r>
+              <a:rPr sz="1150" b="0" i="0">
+                <a:solidFill>
+                  <a:srgbClr val="FFFFFF"/>
+                </a:solidFill>
+              </a:rPr>
+              <a:t>B_confidence is the most injection-robust gate  —  Only −3.6 pp drop at 50% injection — confidence signal already discounts noisy neighbours.</a:t>
+            </a:r>
+          </a:p>
+        </p:txBody>
+      </p:sp>
+      <p:sp>
+        <p:nvSpPr>
+          <p:cNvPr id="53" name="TextBox 52"/>
+          <p:cNvSpPr txBox="1"/>
+          <p:nvPr/>
+        </p:nvSpPr>
+        <p:spPr>
+          <a:xfrm>
+            <a:off x="658368" y="5340096"/>
+            <a:ext cx="256032" cy="384048"/>
+          </a:xfrm>
+          <a:prstGeom prst="rect">
+            <a:avLst/>
+          </a:prstGeom>
+          <a:noFill/>
+        </p:spPr>
+        <p:txBody>
+          <a:bodyPr wrap="square">
+            <a:spAutoFit/>
+          </a:bodyPr>
+          <a:lstStyle/>
+          <a:p>
+            <a:pPr algn="l"/>
+            <a:r>
+              <a:rPr sz="1200" b="1" i="0">
+                <a:solidFill>
+                  <a:srgbClr val="FF4D4D"/>
+                </a:solidFill>
+              </a:rPr>
+              <a:t>▶</a:t>
+            </a:r>
+          </a:p>
+        </p:txBody>
+      </p:sp>
+      <p:sp>
+        <p:nvSpPr>
+          <p:cNvPr id="54" name="TextBox 53"/>
+          <p:cNvSpPr txBox="1"/>
+          <p:nvPr/>
+        </p:nvSpPr>
+        <p:spPr>
+          <a:xfrm>
+            <a:off x="960120" y="5340096"/>
+            <a:ext cx="10515600" cy="384048"/>
+          </a:xfrm>
+          <a:prstGeom prst="rect">
+            <a:avLst/>
+          </a:prstGeom>
+          <a:noFill/>
+        </p:spPr>
+        <p:txBody>
+          <a:bodyPr wrap="square">
+            <a:spAutoFit/>
+          </a:bodyPr>
+          <a:lstStyle/>
+          <a:p>
+            <a:pPr algn="l"/>
+            <a:r>
+              <a:rPr sz="1150" b="0" i="0">
+                <a:solidFill>
+                  <a:srgbClr val="FFFFFF"/>
+                </a:solidFill>
+              </a:rPr>
+              <a:t>D_llm (text cosine) = A_cosine under injection  —  Both drop −8.4 pp. Injected edges are chosen to be text-similar → D trusts the wrong neighbours.</a:t>
+            </a:r>
+          </a:p>
+        </p:txBody>
+      </p:sp>
+      <p:sp>
+        <p:nvSpPr>
+          <p:cNvPr id="55" name="TextBox 54"/>
+          <p:cNvSpPr txBox="1"/>
+          <p:nvPr/>
+        </p:nvSpPr>
+        <p:spPr>
+          <a:xfrm>
+            <a:off x="658368" y="5760720"/>
+            <a:ext cx="256032" cy="384048"/>
+          </a:xfrm>
+          <a:prstGeom prst="rect">
+            <a:avLst/>
+          </a:prstGeom>
+          <a:noFill/>
+        </p:spPr>
+        <p:txBody>
+          <a:bodyPr wrap="square">
+            <a:spAutoFit/>
+          </a:bodyPr>
+          <a:lstStyle/>
+          <a:p>
+            <a:pPr algn="l"/>
+            <a:r>
+              <a:rPr sz="1200" b="1" i="0">
+                <a:solidFill>
+                  <a:srgbClr val="2ECC71"/>
+                </a:solidFill>
+              </a:rPr>
+              <a:t>▶</a:t>
+            </a:r>
+          </a:p>
+        </p:txBody>
+      </p:sp>
+      <p:sp>
+        <p:nvSpPr>
+          <p:cNvPr id="56" name="TextBox 55"/>
+          <p:cNvSpPr txBox="1"/>
+          <p:nvPr/>
+        </p:nvSpPr>
+        <p:spPr>
+          <a:xfrm>
+            <a:off x="960120" y="5760720"/>
+            <a:ext cx="10515600" cy="384048"/>
+          </a:xfrm>
+          <a:prstGeom prst="rect">
+            <a:avLst/>
+          </a:prstGeom>
+          <a:noFill/>
+        </p:spPr>
+        <p:txBody>
+          <a:bodyPr wrap="square">
+            <a:spAutoFit/>
+          </a:bodyPr>
+          <a:lstStyle/>
+          <a:p>
+            <a:pPr algn="l"/>
+            <a:r>
+              <a:rPr sz="1150" b="0" i="0">
+                <a:solidFill>
+                  <a:srgbClr val="FFFFFF"/>
+                </a:solidFill>
+              </a:rPr>
+              <a:t>B and C dominate on heterophily (Texas 81.1%)  —  Outperform standard SAGE (76.6%) and far exceed cosine gates (A: 58.6%, D: 60.4%).</a:t>
+            </a:r>
+          </a:p>
+        </p:txBody>
+      </p:sp>
+      <p:sp>
+        <p:nvSpPr>
+          <p:cNvPr id="57" name="TextBox 56"/>
+          <p:cNvSpPr txBox="1"/>
+          <p:nvPr/>
+        </p:nvSpPr>
+        <p:spPr>
+          <a:xfrm>
+            <a:off x="658368" y="6181344"/>
+            <a:ext cx="256032" cy="384048"/>
+          </a:xfrm>
+          <a:prstGeom prst="rect">
+            <a:avLst/>
+          </a:prstGeom>
+          <a:noFill/>
+        </p:spPr>
+        <p:txBody>
+          <a:bodyPr wrap="square">
+            <a:spAutoFit/>
+          </a:bodyPr>
+          <a:lstStyle/>
+          <a:p>
+            <a:pPr algn="l"/>
+            <a:r>
+              <a:rPr sz="1200" b="1" i="0">
+                <a:solidFill>
+                  <a:srgbClr val="45C4FF"/>
+                </a:solidFill>
+              </a:rPr>
+              <a:t>▶</a:t>
+            </a:r>
+          </a:p>
+        </p:txBody>
+      </p:sp>
+      <p:sp>
+        <p:nvSpPr>
+          <p:cNvPr id="58" name="TextBox 57"/>
+          <p:cNvSpPr txBox="1"/>
+          <p:nvPr/>
+        </p:nvSpPr>
+        <p:spPr>
+          <a:xfrm>
+            <a:off x="960120" y="6181344"/>
+            <a:ext cx="10515600" cy="384048"/>
+          </a:xfrm>
+          <a:prstGeom prst="rect">
+            <a:avLst/>
+          </a:prstGeom>
+          <a:noFill/>
+        </p:spPr>
+        <p:txBody>
+          <a:bodyPr wrap="square">
+            <a:spAutoFit/>
+          </a:bodyPr>
+          <a:lstStyle/>
+          <a:p>
+            <a:pPr algn="l"/>
+            <a:r>
+              <a:rPr sz="1150" b="0" i="0">
+                <a:solidFill>
+                  <a:srgbClr val="FFFFFF"/>
+                </a:solidFill>
+              </a:rPr>
+              <a:t>The full proposal (D with label-support) should beat both stress conditions  —  LLM semantic judgment 'is u relevant for class C?' resists injection and captures heterophily.</a:t>
             </a:r>
           </a:p>
         </p:txBody>

</xml_diff>